<commit_message>
Remove candidate profiles slide from Hank Chu Freedom Plan
Co-Authored-By: Claude Opus 5.5 <noreply@anthropic.com>
Claude-Session: https://claude.ai/code/session_018rW9XDNfHdsFfA3jVzx9xH
</commit_message>
<xml_diff>
--- a/Hank_Chu_Freedom_Plan.pptx
+++ b/Hank_Chu_Freedom_Plan.pptx
@@ -13,7 +13,6 @@
     <p:sldId id="261" r:id="rId7"/>
     <p:sldId id="262" r:id="rId8"/>
     <p:sldId id="263" r:id="rId9"/>
-    <p:sldId id="264" r:id="rId10"/>
     <p:sldId id="265" r:id="rId11"/>
     <p:sldId id="266" r:id="rId12"/>
     <p:sldId id="267" r:id="rId13"/>
@@ -3074,94 +3073,6 @@
             <a:fld id="{F7021451-1387-4CA6-816F-3879F97B5CBC}" type="slidenum">
               <a:rPr lang="en-US"/>
               <a:t>8</a:t>
-            </a:fld>
-            <a:endParaRPr lang="en-US"/>
-          </a:p>
-        </p:txBody>
-      </p:sp>
-    </p:spTree>
-    <p:extLst>
-      <p:ext uri="{BB962C8B-B14F-4D97-AF65-F5344CB8AC3E}">
-        <p14:creationId xmlns:p14="http://schemas.microsoft.com/office/powerpoint/2010/main" val="1024086991"/>
-      </p:ext>
-    </p:extLst>
-  </p:cSld>
-  <p:clrMapOvr>
-    <a:masterClrMapping/>
-  </p:clrMapOvr>
-</p:notes>
-</file>
-
-<file path=ppt/notesSlides/notesSlide9.xml><?xml version="1.0" encoding="utf-8"?>
-<p:notes xmlns:a="http://schemas.openxmlformats.org/drawingml/2006/main" xmlns:r="http://schemas.openxmlformats.org/officeDocument/2006/relationships" xmlns:p="http://schemas.openxmlformats.org/presentationml/2006/main">
-  <p:cSld>
-    <p:spTree>
-      <p:nvGrpSpPr>
-        <p:cNvPr id="1" name=""/>
-        <p:cNvGrpSpPr/>
-        <p:nvPr/>
-      </p:nvGrpSpPr>
-      <p:grpSpPr>
-        <a:xfrm>
-          <a:off x="0" y="0"/>
-          <a:ext cx="0" cy="0"/>
-          <a:chOff x="0" y="0"/>
-          <a:chExt cx="0" cy="0"/>
-        </a:xfrm>
-      </p:grpSpPr>
-      <p:sp>
-        <p:nvSpPr>
-          <p:cNvPr id="2" name="Slide Image Placeholder 1"/>
-          <p:cNvSpPr>
-            <a:spLocks noGrp="1" noRot="1" noChangeAspect="1"/>
-          </p:cNvSpPr>
-          <p:nvPr>
-            <p:ph type="sldImg"/>
-          </p:nvPr>
-        </p:nvSpPr>
-        <p:spPr/>
-      </p:sp>
-      <p:sp>
-        <p:nvSpPr>
-          <p:cNvPr id="3" name="Notes Placeholder 2"/>
-          <p:cNvSpPr>
-            <a:spLocks noGrp="1"/>
-          </p:cNvSpPr>
-          <p:nvPr>
-            <p:ph type="body" idx="1"/>
-          </p:nvPr>
-        </p:nvSpPr>
-        <p:spPr/>
-        <p:txBody>
-          <a:bodyPr/>
-          <a:lstStyle/>
-          <a:p>
-            <a:r>
-              <a:rPr lang="en-US" dirty="0"/>
-              <a:t/>
-            </a:r>
-            <a:endParaRPr lang="en-US" dirty="0"/>
-          </a:p>
-        </p:txBody>
-      </p:sp>
-      <p:sp>
-        <p:nvSpPr>
-          <p:cNvPr id="4" name="Slide Number Placeholder 3"/>
-          <p:cNvSpPr>
-            <a:spLocks noGrp="1"/>
-          </p:cNvSpPr>
-          <p:nvPr>
-            <p:ph type="sldNum" sz="quarter" idx="10"/>
-          </p:nvPr>
-        </p:nvSpPr>
-        <p:spPr/>
-        <p:txBody>
-          <a:bodyPr/>
-          <a:lstStyle/>
-          <a:p>
-            <a:fld id="{F7021451-1387-4CA6-816F-3879F97B5CBC}" type="slidenum">
-              <a:rPr lang="en-US"/>
-              <a:t>9</a:t>
             </a:fld>
             <a:endParaRPr lang="en-US"/>
           </a:p>
@@ -4410,7 +4321,7 @@
                   <a:schemeClr val="accent1"/>
                 </a:solidFill>
               </a:rPr>
-              <a:t>PART A  ·  07</a:t>
+              <a:t>PART A  ·  06</a:t>
             </a:r>
             <a:endParaRPr lang="en-US" sz="1100" dirty="0"/>
           </a:p>
@@ -4968,7 +4879,7 @@
                   <a:schemeClr val="accent1"/>
                 </a:solidFill>
               </a:rPr>
-              <a:t>PART A  ·  08</a:t>
+              <a:t>PART A  ·  07</a:t>
             </a:r>
             <a:endParaRPr lang="en-US" sz="1100" dirty="0"/>
           </a:p>
@@ -13963,7 +13874,7 @@
                   <a:schemeClr val="accent3"/>
                 </a:solidFill>
               </a:rPr>
-              <a:t>What we heard, the role we recommend, your candidates and investment. Read it once, use it to decide.</a:t>
+              <a:t>What we heard, the role we recommend, and the investment. Read it once, use it to decide.</a:t>
             </a:r>
             <a:endParaRPr lang="en-US" sz="1250" dirty="0"/>
           </a:p>
@@ -38218,947 +38129,6 @@
             <a:fld id="{F7021451-1387-4CA6-816F-3879F97B5CBC}" type="slidenum">
               <a:rPr b="0" lang="en-US"/>
               <a:t>8</a:t>
-            </a:fld>
-            <a:endParaRPr lang="en-US"/>
-          </a:p>
-        </p:txBody>
-      </p:sp>
-    </p:spTree>
-  </p:cSld>
-  <p:clrMapOvr>
-    <a:masterClrMapping/>
-  </p:clrMapOvr>
-</p:sld>
-</file>
-
-<file path=ppt/slides/slide9.xml><?xml version="1.0" encoding="utf-8"?>
-<p:sld xmlns:a="http://schemas.openxmlformats.org/drawingml/2006/main" xmlns:r="http://schemas.openxmlformats.org/officeDocument/2006/relationships" xmlns:p="http://schemas.openxmlformats.org/presentationml/2006/main">
-  <p:cSld name="Slide 9">
-    <p:spTree>
-      <p:nvGrpSpPr>
-        <p:cNvPr id="1" name=""/>
-        <p:cNvGrpSpPr/>
-        <p:nvPr/>
-      </p:nvGrpSpPr>
-      <p:grpSpPr>
-        <a:xfrm>
-          <a:off x="0" y="0"/>
-          <a:ext cx="0" cy="0"/>
-          <a:chOff x="0" y="0"/>
-          <a:chExt cx="0" cy="0"/>
-        </a:xfrm>
-      </p:grpSpPr>
-      <p:sp>
-        <p:nvSpPr>
-          <p:cNvPr id="2" name="Text 1"/>
-          <p:cNvSpPr/>
-          <p:nvPr>
-            <p:ph idx="101" type="body" hasCustomPrompt="1"/>
-          </p:nvPr>
-        </p:nvSpPr>
-        <p:spPr>
-          <a:xfrm>
-            <a:off x="630936" y="411480"/>
-            <a:ext cx="10058400" cy="274320"/>
-          </a:xfrm>
-          <a:prstGeom prst="rect">
-            <a:avLst/>
-          </a:prstGeom>
-          <a:noFill/>
-          <a:ln/>
-        </p:spPr>
-        <p:txBody>
-          <a:bodyPr wrap="square" lIns="0" tIns="0" rIns="0" bIns="0" rtlCol="0" anchor="ctr"/>
-          <a:lstStyle/>
-          <a:p>
-            <a:pPr indent="0" marL="0">
-              <a:buNone/>
-            </a:pPr>
-            <a:r>
-              <a:rPr lang="en-US" sz="1100" b="1" spc="200" kern="0" dirty="0">
-                <a:solidFill>
-                  <a:schemeClr val="accent1"/>
-                </a:solidFill>
-              </a:rPr>
-              <a:t>PART A  ·  06  ·  DISCOVER</a:t>
-            </a:r>
-            <a:endParaRPr lang="en-US" sz="1100" dirty="0"/>
-          </a:p>
-        </p:txBody>
-      </p:sp>
-      <p:sp>
-        <p:nvSpPr>
-          <p:cNvPr id="3" name="Text 1"/>
-          <p:cNvSpPr/>
-          <p:nvPr>
-            <p:ph idx="102" type="title" hasCustomPrompt="1"/>
-          </p:nvPr>
-        </p:nvSpPr>
-        <p:spPr>
-          <a:xfrm>
-            <a:off x="630936" y="731520"/>
-            <a:ext cx="10515600" cy="594360"/>
-          </a:xfrm>
-          <a:prstGeom prst="rect">
-            <a:avLst/>
-          </a:prstGeom>
-          <a:noFill/>
-          <a:ln/>
-        </p:spPr>
-        <p:txBody>
-          <a:bodyPr wrap="square" lIns="0" tIns="0" rIns="0" bIns="0" rtlCol="0" anchor="ctr"/>
-          <a:lstStyle/>
-          <a:p>
-            <a:pPr algn="l" indent="0" marL="0">
-              <a:buNone/>
-            </a:pPr>
-            <a:r>
-              <a:rPr lang="en-US" sz="3000" b="1" dirty="0">
-                <a:solidFill>
-                  <a:schemeClr val="tx1"/>
-                </a:solidFill>
-                <a:latin typeface="Cambria" pitchFamily="34" charset="0"/>
-                <a:ea typeface="Cambria" pitchFamily="34" charset="-122"/>
-                <a:cs typeface="Cambria" pitchFamily="34" charset="-120"/>
-              </a:rPr>
-              <a:t>Your Candidates</a:t>
-            </a:r>
-            <a:endParaRPr lang="en-US" sz="3000" dirty="0"/>
-          </a:p>
-        </p:txBody>
-      </p:sp>
-      <p:sp>
-        <p:nvSpPr>
-          <p:cNvPr id="4" name="Text 2"/>
-          <p:cNvSpPr txBox="1"/>
-          <p:nvPr/>
-        </p:nvSpPr>
-        <p:spPr>
-          <a:xfrm>
-            <a:off x="630936" y="1371600"/>
-            <a:ext cx="10929823" cy="457200"/>
-          </a:xfrm>
-          <a:prstGeom prst="rect">
-            <a:avLst/>
-          </a:prstGeom>
-          <a:noFill/>
-          <a:ln/>
-        </p:spPr>
-        <p:txBody>
-          <a:bodyPr wrap="square" lIns="0" tIns="0" rIns="0" bIns="0" rtlCol="0" anchor="t"/>
-          <a:lstStyle/>
-          <a:p>
-            <a:pPr indent="0" marL="0">
-              <a:buNone/>
-            </a:pPr>
-            <a:r>
-              <a:rPr lang="en-US" sz="1300" dirty="0">
-                <a:solidFill>
-                  <a:schemeClr val="accent3"/>
-                </a:solidFill>
-              </a:rPr>
-              <a:t>Shortlisted and shared on 14 October, with interviews now booked. Click through to each full profile.</a:t>
-            </a:r>
-            <a:endParaRPr lang="en-US" sz="1300" dirty="0"/>
-          </a:p>
-        </p:txBody>
-      </p:sp>
-      <p:sp>
-        <p:nvSpPr>
-          <p:cNvPr id="5" name="card"/>
-          <p:cNvSpPr/>
-          <p:nvPr/>
-        </p:nvSpPr>
-        <p:spPr>
-          <a:xfrm>
-            <a:off x="630936" y="1965960"/>
-            <a:ext cx="3521354" cy="3383280"/>
-          </a:xfrm>
-          <a:prstGeom prst="roundRect">
-            <a:avLst>
-              <a:gd name="adj" fmla="val 2162"/>
-            </a:avLst>
-          </a:prstGeom>
-          <a:solidFill>
-            <a:schemeClr val="bg1"/>
-          </a:solidFill>
-          <a:ln w="12700">
-            <a:solidFill>
-              <a:schemeClr val="accent5"/>
-            </a:solidFill>
-            <a:prstDash val="solid"/>
-          </a:ln>
-        </p:spPr>
-      </p:sp>
-      <p:sp>
-        <p:nvSpPr>
-          <p:cNvPr id="6" name="avatar Irah Rose"/>
-          <p:cNvSpPr/>
-          <p:nvPr/>
-        </p:nvSpPr>
-        <p:spPr>
-          <a:xfrm>
-            <a:off x="905256" y="2240280"/>
-            <a:ext cx="594360" cy="594360"/>
-          </a:xfrm>
-          <a:prstGeom prst="ellipse">
-            <a:avLst/>
-          </a:prstGeom>
-          <a:solidFill>
-            <a:schemeClr val="accent4"/>
-          </a:solidFill>
-          <a:ln/>
-        </p:spPr>
-      </p:sp>
-      <p:sp>
-        <p:nvSpPr>
-          <p:cNvPr id="7" name="Text 5"/>
-          <p:cNvSpPr txBox="1"/>
-          <p:nvPr/>
-        </p:nvSpPr>
-        <p:spPr>
-          <a:xfrm>
-            <a:off x="905256" y="2240280"/>
-            <a:ext cx="594360" cy="594360"/>
-          </a:xfrm>
-          <a:prstGeom prst="rect">
-            <a:avLst/>
-          </a:prstGeom>
-          <a:noFill/>
-          <a:ln/>
-        </p:spPr>
-        <p:txBody>
-          <a:bodyPr wrap="square" lIns="0" tIns="0" rIns="0" bIns="0" rtlCol="0" anchor="ctr"/>
-          <a:lstStyle/>
-          <a:p>
-            <a:pPr algn="ctr" indent="0" marL="0">
-              <a:buNone/>
-            </a:pPr>
-            <a:r>
-              <a:rPr lang="en-US" sz="2000" b="1" dirty="0">
-                <a:solidFill>
-                  <a:schemeClr val="accent1"/>
-                </a:solidFill>
-                <a:latin typeface="Cambria" pitchFamily="34" charset="0"/>
-                <a:ea typeface="Cambria" pitchFamily="34" charset="-122"/>
-                <a:cs typeface="Cambria" pitchFamily="34" charset="-120"/>
-              </a:rPr>
-              <a:t>I</a:t>
-            </a:r>
-            <a:endParaRPr lang="en-US" sz="2000" dirty="0"/>
-          </a:p>
-        </p:txBody>
-      </p:sp>
-      <p:sp>
-        <p:nvSpPr>
-          <p:cNvPr id="8" name="Text 6"/>
-          <p:cNvSpPr txBox="1"/>
-          <p:nvPr/>
-        </p:nvSpPr>
-        <p:spPr>
-          <a:xfrm>
-            <a:off x="1636776" y="2240280"/>
-            <a:ext cx="2332634" cy="320040"/>
-          </a:xfrm>
-          <a:prstGeom prst="rect">
-            <a:avLst/>
-          </a:prstGeom>
-          <a:noFill/>
-          <a:ln/>
-        </p:spPr>
-        <p:txBody>
-          <a:bodyPr wrap="square" lIns="0" tIns="0" rIns="0" bIns="0" rtlCol="0" anchor="ctr"/>
-          <a:lstStyle/>
-          <a:p>
-            <a:pPr indent="0" marL="0">
-              <a:buNone/>
-            </a:pPr>
-            <a:r>
-              <a:rPr lang="en-US" sz="1600" b="1" dirty="0">
-                <a:solidFill>
-                  <a:schemeClr val="tx1"/>
-                </a:solidFill>
-                <a:latin typeface="Cambria" pitchFamily="34" charset="0"/>
-                <a:ea typeface="Cambria" pitchFamily="34" charset="-122"/>
-                <a:cs typeface="Cambria" pitchFamily="34" charset="-120"/>
-              </a:rPr>
-              <a:t>Irah Rose</a:t>
-            </a:r>
-            <a:endParaRPr lang="en-US" sz="1600" dirty="0"/>
-          </a:p>
-        </p:txBody>
-      </p:sp>
-      <p:sp>
-        <p:nvSpPr>
-          <p:cNvPr id="9" name="Text 7"/>
-          <p:cNvSpPr txBox="1"/>
-          <p:nvPr/>
-        </p:nvSpPr>
-        <p:spPr>
-          <a:xfrm>
-            <a:off x="1636776" y="2560320"/>
-            <a:ext cx="2332634" cy="274320"/>
-          </a:xfrm>
-          <a:prstGeom prst="rect">
-            <a:avLst/>
-          </a:prstGeom>
-          <a:noFill/>
-          <a:ln/>
-        </p:spPr>
-        <p:txBody>
-          <a:bodyPr wrap="square" lIns="0" tIns="0" rIns="0" bIns="0" rtlCol="0" anchor="ctr"/>
-          <a:lstStyle/>
-          <a:p>
-            <a:pPr indent="0" marL="0">
-              <a:buNone/>
-            </a:pPr>
-            <a:r>
-              <a:rPr lang="en-US" sz="1150" b="1" dirty="0">
-                <a:solidFill>
-                  <a:schemeClr val="accent1"/>
-                </a:solidFill>
-              </a:rPr>
-              <a:t>Shortlisted</a:t>
-            </a:r>
-            <a:endParaRPr lang="en-US" sz="1150" dirty="0"/>
-          </a:p>
-        </p:txBody>
-      </p:sp>
-      <p:sp>
-        <p:nvSpPr>
-          <p:cNvPr id="10" name="Text 8"/>
-          <p:cNvSpPr txBox="1"/>
-          <p:nvPr/>
-        </p:nvSpPr>
-        <p:spPr>
-          <a:xfrm>
-            <a:off x="905256" y="3063240"/>
-            <a:ext cx="2972714" cy="1554480"/>
-          </a:xfrm>
-          <a:prstGeom prst="rect">
-            <a:avLst/>
-          </a:prstGeom>
-          <a:noFill/>
-          <a:ln/>
-        </p:spPr>
-        <p:txBody>
-          <a:bodyPr wrap="square" lIns="0" tIns="0" rIns="0" bIns="0" rtlCol="0" anchor="t"/>
-          <a:lstStyle/>
-          <a:p>
-            <a:pPr indent="0" marL="0">
-              <a:buNone/>
-            </a:pPr>
-            <a:r>
-              <a:rPr lang="en-US" sz="1200" dirty="0">
-                <a:solidFill>
-                  <a:schemeClr val="accent3"/>
-                </a:solidFill>
-              </a:rPr>
-              <a:t>8 years customer-facing, including collections and overdue-payment follow-up. Shopify listings and confirmation calls as a remote VA; HubSpot, Gorgias, Freshdesk.</a:t>
-            </a:r>
-            <a:endParaRPr lang="en-US" sz="1200" dirty="0"/>
-          </a:p>
-        </p:txBody>
-      </p:sp>
-      <p:sp>
-        <p:nvSpPr>
-          <p:cNvPr id="11" name="Text 9"/>
-          <p:cNvSpPr txBox="1"/>
-          <p:nvPr/>
-        </p:nvSpPr>
-        <p:spPr>
-          <a:xfrm>
-            <a:off x="905256" y="4754880"/>
-            <a:ext cx="2972714" cy="320040"/>
-          </a:xfrm>
-          <a:prstGeom prst="rect">
-            <a:avLst/>
-          </a:prstGeom>
-          <a:noFill/>
-          <a:ln/>
-        </p:spPr>
-        <p:txBody>
-          <a:bodyPr wrap="square" lIns="0" tIns="0" rIns="0" bIns="0" rtlCol="0" anchor="ctr"/>
-          <a:lstStyle/>
-          <a:p>
-            <a:pPr indent="0" marL="0">
-              <a:buNone/>
-            </a:pPr>
-            <a:r>
-              <a:rPr lang="en-US" sz="1200" b="1" u="sng" dirty="0">
-                <a:solidFill>
-                  <a:schemeClr val="accent1"/>
-                </a:solidFill>
-                <a:hlinkClick r:id="rId1" invalidUrl="" action="" tgtFrame="" tooltip="" history="1" highlightClick="0" endSnd="0">
-                  <a:extLst>
-                    <a:ext uri="{A12FA001-AC4F-418D-AE19-62706E023703}">
-                      <ahyp:hlinkClr xmlns:ahyp="http://schemas.microsoft.com/office/drawing/2018/hyperlinkcolor" val="tx"/>
-                    </a:ext>
-                  </a:extLst>
-                </a:hlinkClick>
-              </a:rPr>
-              <a:t>View full profile →</a:t>
-            </a:r>
-            <a:endParaRPr lang="en-US" sz="1200" dirty="0"/>
-          </a:p>
-        </p:txBody>
-      </p:sp>
-      <p:sp>
-        <p:nvSpPr>
-          <p:cNvPr id="12" name="card"/>
-          <p:cNvSpPr/>
-          <p:nvPr/>
-        </p:nvSpPr>
-        <p:spPr>
-          <a:xfrm>
-            <a:off x="4335170" y="1965960"/>
-            <a:ext cx="3521354" cy="3383280"/>
-          </a:xfrm>
-          <a:prstGeom prst="roundRect">
-            <a:avLst>
-              <a:gd name="adj" fmla="val 2162"/>
-            </a:avLst>
-          </a:prstGeom>
-          <a:solidFill>
-            <a:schemeClr val="bg1"/>
-          </a:solidFill>
-          <a:ln w="12700">
-            <a:solidFill>
-              <a:schemeClr val="accent5"/>
-            </a:solidFill>
-            <a:prstDash val="solid"/>
-          </a:ln>
-        </p:spPr>
-      </p:sp>
-      <p:sp>
-        <p:nvSpPr>
-          <p:cNvPr id="13" name="avatar Anamari"/>
-          <p:cNvSpPr/>
-          <p:nvPr/>
-        </p:nvSpPr>
-        <p:spPr>
-          <a:xfrm>
-            <a:off x="4609490" y="2240280"/>
-            <a:ext cx="594360" cy="594360"/>
-          </a:xfrm>
-          <a:prstGeom prst="ellipse">
-            <a:avLst/>
-          </a:prstGeom>
-          <a:solidFill>
-            <a:schemeClr val="accent4"/>
-          </a:solidFill>
-          <a:ln/>
-        </p:spPr>
-      </p:sp>
-      <p:sp>
-        <p:nvSpPr>
-          <p:cNvPr id="14" name="Text 12"/>
-          <p:cNvSpPr txBox="1"/>
-          <p:nvPr/>
-        </p:nvSpPr>
-        <p:spPr>
-          <a:xfrm>
-            <a:off x="4609490" y="2240280"/>
-            <a:ext cx="594360" cy="594360"/>
-          </a:xfrm>
-          <a:prstGeom prst="rect">
-            <a:avLst/>
-          </a:prstGeom>
-          <a:noFill/>
-          <a:ln/>
-        </p:spPr>
-        <p:txBody>
-          <a:bodyPr wrap="square" lIns="0" tIns="0" rIns="0" bIns="0" rtlCol="0" anchor="ctr"/>
-          <a:lstStyle/>
-          <a:p>
-            <a:pPr algn="ctr" indent="0" marL="0">
-              <a:buNone/>
-            </a:pPr>
-            <a:r>
-              <a:rPr lang="en-US" sz="2000" b="1" dirty="0">
-                <a:solidFill>
-                  <a:schemeClr val="accent1"/>
-                </a:solidFill>
-                <a:latin typeface="Cambria" pitchFamily="34" charset="0"/>
-                <a:ea typeface="Cambria" pitchFamily="34" charset="-122"/>
-                <a:cs typeface="Cambria" pitchFamily="34" charset="-120"/>
-              </a:rPr>
-              <a:t>A</a:t>
-            </a:r>
-            <a:endParaRPr lang="en-US" sz="2000" dirty="0"/>
-          </a:p>
-        </p:txBody>
-      </p:sp>
-      <p:sp>
-        <p:nvSpPr>
-          <p:cNvPr id="15" name="Text 13"/>
-          <p:cNvSpPr txBox="1"/>
-          <p:nvPr/>
-        </p:nvSpPr>
-        <p:spPr>
-          <a:xfrm>
-            <a:off x="5341010" y="2240280"/>
-            <a:ext cx="2332634" cy="320040"/>
-          </a:xfrm>
-          <a:prstGeom prst="rect">
-            <a:avLst/>
-          </a:prstGeom>
-          <a:noFill/>
-          <a:ln/>
-        </p:spPr>
-        <p:txBody>
-          <a:bodyPr wrap="square" lIns="0" tIns="0" rIns="0" bIns="0" rtlCol="0" anchor="ctr"/>
-          <a:lstStyle/>
-          <a:p>
-            <a:pPr indent="0" marL="0">
-              <a:buNone/>
-            </a:pPr>
-            <a:r>
-              <a:rPr lang="en-US" sz="1600" b="1" dirty="0">
-                <a:solidFill>
-                  <a:schemeClr val="tx1"/>
-                </a:solidFill>
-                <a:latin typeface="Cambria" pitchFamily="34" charset="0"/>
-                <a:ea typeface="Cambria" pitchFamily="34" charset="-122"/>
-                <a:cs typeface="Cambria" pitchFamily="34" charset="-120"/>
-              </a:rPr>
-              <a:t>Anamari</a:t>
-            </a:r>
-            <a:endParaRPr lang="en-US" sz="1600" dirty="0"/>
-          </a:p>
-        </p:txBody>
-      </p:sp>
-      <p:sp>
-        <p:nvSpPr>
-          <p:cNvPr id="16" name="Text 14"/>
-          <p:cNvSpPr txBox="1"/>
-          <p:nvPr/>
-        </p:nvSpPr>
-        <p:spPr>
-          <a:xfrm>
-            <a:off x="5341010" y="2560320"/>
-            <a:ext cx="2332634" cy="274320"/>
-          </a:xfrm>
-          <a:prstGeom prst="rect">
-            <a:avLst/>
-          </a:prstGeom>
-          <a:noFill/>
-          <a:ln/>
-        </p:spPr>
-        <p:txBody>
-          <a:bodyPr wrap="square" lIns="0" tIns="0" rIns="0" bIns="0" rtlCol="0" anchor="ctr"/>
-          <a:lstStyle/>
-          <a:p>
-            <a:pPr indent="0" marL="0">
-              <a:buNone/>
-            </a:pPr>
-            <a:r>
-              <a:rPr lang="en-US" sz="1150" b="1" dirty="0">
-                <a:solidFill>
-                  <a:schemeClr val="accent1"/>
-                </a:solidFill>
-              </a:rPr>
-              <a:t>Shortlisted</a:t>
-            </a:r>
-            <a:endParaRPr lang="en-US" sz="1150" dirty="0"/>
-          </a:p>
-        </p:txBody>
-      </p:sp>
-      <p:sp>
-        <p:nvSpPr>
-          <p:cNvPr id="17" name="Text 15"/>
-          <p:cNvSpPr txBox="1"/>
-          <p:nvPr/>
-        </p:nvSpPr>
-        <p:spPr>
-          <a:xfrm>
-            <a:off x="4609490" y="3063240"/>
-            <a:ext cx="2972714" cy="1554480"/>
-          </a:xfrm>
-          <a:prstGeom prst="rect">
-            <a:avLst/>
-          </a:prstGeom>
-          <a:noFill/>
-          <a:ln/>
-        </p:spPr>
-        <p:txBody>
-          <a:bodyPr wrap="square" lIns="0" tIns="0" rIns="0" bIns="0" rtlCol="0" anchor="t"/>
-          <a:lstStyle/>
-          <a:p>
-            <a:pPr indent="0" marL="0">
-              <a:buNone/>
-            </a:pPr>
-            <a:r>
-              <a:rPr lang="en-US" sz="1200" dirty="0">
-                <a:solidFill>
-                  <a:schemeClr val="accent3"/>
-                </a:solidFill>
-              </a:rPr>
-              <a:t>Tier 3 customer service resolutions across phone, email and chat. Took and dispatched orders for a food delivery business; Shopify, WhatsApp, Excel, Zoho.</a:t>
-            </a:r>
-            <a:endParaRPr lang="en-US" sz="1200" dirty="0"/>
-          </a:p>
-        </p:txBody>
-      </p:sp>
-      <p:sp>
-        <p:nvSpPr>
-          <p:cNvPr id="18" name="Text 16"/>
-          <p:cNvSpPr txBox="1"/>
-          <p:nvPr/>
-        </p:nvSpPr>
-        <p:spPr>
-          <a:xfrm>
-            <a:off x="4609490" y="4754880"/>
-            <a:ext cx="2972714" cy="320040"/>
-          </a:xfrm>
-          <a:prstGeom prst="rect">
-            <a:avLst/>
-          </a:prstGeom>
-          <a:noFill/>
-          <a:ln/>
-        </p:spPr>
-        <p:txBody>
-          <a:bodyPr wrap="square" lIns="0" tIns="0" rIns="0" bIns="0" rtlCol="0" anchor="ctr"/>
-          <a:lstStyle/>
-          <a:p>
-            <a:pPr indent="0" marL="0">
-              <a:buNone/>
-            </a:pPr>
-            <a:r>
-              <a:rPr lang="en-US" sz="1200" b="1" u="sng" dirty="0">
-                <a:solidFill>
-                  <a:schemeClr val="accent1"/>
-                </a:solidFill>
-                <a:hlinkClick r:id="rId2" invalidUrl="" action="" tgtFrame="" tooltip="" history="1" highlightClick="0" endSnd="0">
-                  <a:extLst>
-                    <a:ext uri="{A12FA001-AC4F-418D-AE19-62706E023703}">
-                      <ahyp:hlinkClr xmlns:ahyp="http://schemas.microsoft.com/office/drawing/2018/hyperlinkcolor" val="tx"/>
-                    </a:ext>
-                  </a:extLst>
-                </a:hlinkClick>
-              </a:rPr>
-              <a:t>View full profile →</a:t>
-            </a:r>
-            <a:endParaRPr lang="en-US" sz="1200" dirty="0"/>
-          </a:p>
-        </p:txBody>
-      </p:sp>
-      <p:sp>
-        <p:nvSpPr>
-          <p:cNvPr id="19" name="card"/>
-          <p:cNvSpPr/>
-          <p:nvPr/>
-        </p:nvSpPr>
-        <p:spPr>
-          <a:xfrm>
-            <a:off x="8039405" y="1965960"/>
-            <a:ext cx="3521354" cy="3383280"/>
-          </a:xfrm>
-          <a:prstGeom prst="roundRect">
-            <a:avLst>
-              <a:gd name="adj" fmla="val 2162"/>
-            </a:avLst>
-          </a:prstGeom>
-          <a:solidFill>
-            <a:schemeClr val="bg1"/>
-          </a:solidFill>
-          <a:ln w="12700">
-            <a:solidFill>
-              <a:schemeClr val="accent5"/>
-            </a:solidFill>
-            <a:prstDash val="solid"/>
-          </a:ln>
-        </p:spPr>
-      </p:sp>
-      <p:sp>
-        <p:nvSpPr>
-          <p:cNvPr id="20" name="avatar Ysabel"/>
-          <p:cNvSpPr/>
-          <p:nvPr/>
-        </p:nvSpPr>
-        <p:spPr>
-          <a:xfrm>
-            <a:off x="8313725" y="2240280"/>
-            <a:ext cx="594360" cy="594360"/>
-          </a:xfrm>
-          <a:prstGeom prst="ellipse">
-            <a:avLst/>
-          </a:prstGeom>
-          <a:solidFill>
-            <a:schemeClr val="accent4"/>
-          </a:solidFill>
-          <a:ln/>
-        </p:spPr>
-      </p:sp>
-      <p:sp>
-        <p:nvSpPr>
-          <p:cNvPr id="21" name="Text 19"/>
-          <p:cNvSpPr txBox="1"/>
-          <p:nvPr/>
-        </p:nvSpPr>
-        <p:spPr>
-          <a:xfrm>
-            <a:off x="8313725" y="2240280"/>
-            <a:ext cx="594360" cy="594360"/>
-          </a:xfrm>
-          <a:prstGeom prst="rect">
-            <a:avLst/>
-          </a:prstGeom>
-          <a:noFill/>
-          <a:ln/>
-        </p:spPr>
-        <p:txBody>
-          <a:bodyPr wrap="square" lIns="0" tIns="0" rIns="0" bIns="0" rtlCol="0" anchor="ctr"/>
-          <a:lstStyle/>
-          <a:p>
-            <a:pPr algn="ctr" indent="0" marL="0">
-              <a:buNone/>
-            </a:pPr>
-            <a:r>
-              <a:rPr lang="en-US" sz="2000" b="1" dirty="0">
-                <a:solidFill>
-                  <a:schemeClr val="accent1"/>
-                </a:solidFill>
-                <a:latin typeface="Cambria" pitchFamily="34" charset="0"/>
-                <a:ea typeface="Cambria" pitchFamily="34" charset="-122"/>
-                <a:cs typeface="Cambria" pitchFamily="34" charset="-120"/>
-              </a:rPr>
-              <a:t>Y</a:t>
-            </a:r>
-            <a:endParaRPr lang="en-US" sz="2000" dirty="0"/>
-          </a:p>
-        </p:txBody>
-      </p:sp>
-      <p:sp>
-        <p:nvSpPr>
-          <p:cNvPr id="22" name="Text 20"/>
-          <p:cNvSpPr txBox="1"/>
-          <p:nvPr/>
-        </p:nvSpPr>
-        <p:spPr>
-          <a:xfrm>
-            <a:off x="9045245" y="2240280"/>
-            <a:ext cx="2332634" cy="320040"/>
-          </a:xfrm>
-          <a:prstGeom prst="rect">
-            <a:avLst/>
-          </a:prstGeom>
-          <a:noFill/>
-          <a:ln/>
-        </p:spPr>
-        <p:txBody>
-          <a:bodyPr wrap="square" lIns="0" tIns="0" rIns="0" bIns="0" rtlCol="0" anchor="ctr"/>
-          <a:lstStyle/>
-          <a:p>
-            <a:pPr indent="0" marL="0">
-              <a:buNone/>
-            </a:pPr>
-            <a:r>
-              <a:rPr lang="en-US" sz="1600" b="1" dirty="0">
-                <a:solidFill>
-                  <a:schemeClr val="tx1"/>
-                </a:solidFill>
-                <a:latin typeface="Cambria" pitchFamily="34" charset="0"/>
-                <a:ea typeface="Cambria" pitchFamily="34" charset="-122"/>
-                <a:cs typeface="Cambria" pitchFamily="34" charset="-120"/>
-              </a:rPr>
-              <a:t>Ysabel</a:t>
-            </a:r>
-            <a:endParaRPr lang="en-US" sz="1600" dirty="0"/>
-          </a:p>
-        </p:txBody>
-      </p:sp>
-      <p:sp>
-        <p:nvSpPr>
-          <p:cNvPr id="23" name="Text 21"/>
-          <p:cNvSpPr txBox="1"/>
-          <p:nvPr/>
-        </p:nvSpPr>
-        <p:spPr>
-          <a:xfrm>
-            <a:off x="9045245" y="2560320"/>
-            <a:ext cx="2332634" cy="274320"/>
-          </a:xfrm>
-          <a:prstGeom prst="rect">
-            <a:avLst/>
-          </a:prstGeom>
-          <a:noFill/>
-          <a:ln/>
-        </p:spPr>
-        <p:txBody>
-          <a:bodyPr wrap="square" lIns="0" tIns="0" rIns="0" bIns="0" rtlCol="0" anchor="ctr"/>
-          <a:lstStyle/>
-          <a:p>
-            <a:pPr indent="0" marL="0">
-              <a:buNone/>
-            </a:pPr>
-            <a:r>
-              <a:rPr lang="en-US" sz="1150" b="1" dirty="0">
-                <a:solidFill>
-                  <a:schemeClr val="accent1"/>
-                </a:solidFill>
-              </a:rPr>
-              <a:t>Shortlisted</a:t>
-            </a:r>
-            <a:endParaRPr lang="en-US" sz="1150" dirty="0"/>
-          </a:p>
-        </p:txBody>
-      </p:sp>
-      <p:sp>
-        <p:nvSpPr>
-          <p:cNvPr id="24" name="Text 22"/>
-          <p:cNvSpPr txBox="1"/>
-          <p:nvPr/>
-        </p:nvSpPr>
-        <p:spPr>
-          <a:xfrm>
-            <a:off x="8313725" y="3063240"/>
-            <a:ext cx="2972714" cy="1554480"/>
-          </a:xfrm>
-          <a:prstGeom prst="rect">
-            <a:avLst/>
-          </a:prstGeom>
-          <a:noFill/>
-          <a:ln/>
-        </p:spPr>
-        <p:txBody>
-          <a:bodyPr wrap="square" lIns="0" tIns="0" rIns="0" bIns="0" rtlCol="0" anchor="t"/>
-          <a:lstStyle/>
-          <a:p>
-            <a:pPr indent="0" marL="0">
-              <a:buNone/>
-            </a:pPr>
-            <a:r>
-              <a:rPr lang="en-US" sz="1200" dirty="0">
-                <a:solidFill>
-                  <a:schemeClr val="accent3"/>
-                </a:solidFill>
-              </a:rPr>
-              <a:t>4+ years supporting Australian and UK customers: order tracking, payments, delivery delays and escalations. Shopify, WooCommerce, Gorgias, Zendesk.</a:t>
-            </a:r>
-            <a:endParaRPr lang="en-US" sz="1200" dirty="0"/>
-          </a:p>
-        </p:txBody>
-      </p:sp>
-      <p:sp>
-        <p:nvSpPr>
-          <p:cNvPr id="25" name="Text 23"/>
-          <p:cNvSpPr txBox="1"/>
-          <p:nvPr/>
-        </p:nvSpPr>
-        <p:spPr>
-          <a:xfrm>
-            <a:off x="8313725" y="4754880"/>
-            <a:ext cx="2972714" cy="320040"/>
-          </a:xfrm>
-          <a:prstGeom prst="rect">
-            <a:avLst/>
-          </a:prstGeom>
-          <a:noFill/>
-          <a:ln/>
-        </p:spPr>
-        <p:txBody>
-          <a:bodyPr wrap="square" lIns="0" tIns="0" rIns="0" bIns="0" rtlCol="0" anchor="ctr"/>
-          <a:lstStyle/>
-          <a:p>
-            <a:pPr indent="0" marL="0">
-              <a:buNone/>
-            </a:pPr>
-            <a:r>
-              <a:rPr lang="en-US" sz="1200" b="1" u="sng" dirty="0">
-                <a:solidFill>
-                  <a:schemeClr val="accent1"/>
-                </a:solidFill>
-                <a:hlinkClick r:id="rId3" invalidUrl="" action="" tgtFrame="" tooltip="" history="1" highlightClick="0" endSnd="0">
-                  <a:extLst>
-                    <a:ext uri="{A12FA001-AC4F-418D-AE19-62706E023703}">
-                      <ahyp:hlinkClr xmlns:ahyp="http://schemas.microsoft.com/office/drawing/2018/hyperlinkcolor" val="tx"/>
-                    </a:ext>
-                  </a:extLst>
-                </a:hlinkClick>
-              </a:rPr>
-              <a:t>View full profile →</a:t>
-            </a:r>
-            <a:endParaRPr lang="en-US" sz="1200" dirty="0"/>
-          </a:p>
-        </p:txBody>
-      </p:sp>
-      <p:sp>
-        <p:nvSpPr>
-          <p:cNvPr id="26" name="Text 24"/>
-          <p:cNvSpPr txBox="1"/>
-          <p:nvPr/>
-        </p:nvSpPr>
-        <p:spPr>
-          <a:xfrm>
-            <a:off x="630936" y="5577840"/>
-            <a:ext cx="10929823" cy="320040"/>
-          </a:xfrm>
-          <a:prstGeom prst="rect">
-            <a:avLst/>
-          </a:prstGeom>
-          <a:noFill/>
-          <a:ln/>
-        </p:spPr>
-        <p:txBody>
-          <a:bodyPr wrap="square" lIns="0" tIns="0" rIns="0" bIns="0" rtlCol="0" anchor="ctr"/>
-          <a:lstStyle/>
-          <a:p>
-            <a:pPr indent="0" marL="0">
-              <a:buNone/>
-            </a:pPr>
-            <a:r>
-              <a:rPr lang="en-US" sz="1150" i="1" dirty="0">
-                <a:solidFill>
-                  <a:schemeClr val="accent3"/>
-                </a:solidFill>
-              </a:rPr>
-              <a:t>Also shared on 14 October: Grazielle and Mariel. An optional skills test can be arranged before you decide.</a:t>
-            </a:r>
-            <a:endParaRPr lang="en-US" sz="1150" dirty="0"/>
-          </a:p>
-        </p:txBody>
-      </p:sp>
-      <p:sp>
-        <p:nvSpPr>
-          <p:cNvPr id="25" name="Slide Number Placeholder 0"/>
-          <p:cNvSpPr>
-            <a:spLocks noGrp="1"/>
-          </p:cNvSpPr>
-          <p:nvPr>
-            <p:ph type="sldNum" sz="quarter" idx="4294967295"/>
-          </p:nvPr>
-        </p:nvSpPr>
-        <p:spPr>
-          <a:xfrm>
-            <a:off x="11012119" y="6446520"/>
-            <a:ext cx="548640" cy="228600"/>
-          </a:xfrm>
-          <a:prstGeom prst="rect">
-            <a:avLst/>
-          </a:prstGeom>
-          <a:extLst>
-            <a:ext uri="{C572A759-6A51-4108-AA02-DFA0A04FC94B}">
-              <ma14:wrappingTextBoxFlag xmlns:ma14="http://schemas.microsoft.com/office/mac/drawingml/2011/main" val="0"/>
-            </a:ext>
-          </a:extLst>
-        </p:spPr>
-        <p:txBody>
-          <a:bodyPr/>
-          <a:lstStyle>
-            <a:lvl1pPr>
-              <a:defRPr sz="800">
-                <a:solidFill>
-                  <a:schemeClr val="accent3"/>
-                </a:solidFill>
-              </a:defRPr>
-            </a:lvl1pPr>
-          </a:lstStyle>
-          <a:p>
-            <a:pPr algn="r"/>
-            <a:fld id="{F7021451-1387-4CA6-816F-3879F97B5CBC}" type="slidenum">
-              <a:rPr b="0" lang="en-US"/>
-              <a:t>9</a:t>
             </a:fld>
             <a:endParaRPr lang="en-US"/>
           </a:p>

</xml_diff>